<commit_message>
Improve gsm8k answer visibility and citation wording
</commit_message>
<xml_diff>
--- a/slides/datasets-in-10-minutes-gsm8k.pptx
+++ b/slides/datasets-in-10-minutes-gsm8k.pptx
@@ -12465,7 +12465,7 @@
                 <a:ea typeface="Noto Sans CJK JP"/>
                 <a:cs typeface="Noto Sans"/>
               </a:rPr>
-              <a:t>同報告のTable 3、chain-of-thought条件。モデル名の7B・72Bは規模を表す。</a:t>
+              <a:t>chain-of-thought条件。モデル名の7B・72Bは規模を表す。</a:t>
             </a:r>
           </a:p>
         </p:txBody>
@@ -13381,7 +13381,7 @@
                 <a:ea typeface="Noto Sans CJK JP"/>
                 <a:cs typeface="Noto Sans"/>
               </a:rPr>
-              <a:t>2024年のTable 3。最後の行はmaj@8で、8候補から答えを選ぶ。</a:t>
+              <a:t>最後の行はmaj@8で、8候補から答えを選ぶ。</a:t>
             </a:r>
           </a:p>
         </p:txBody>

</xml_diff>